<commit_message>
Spectrum decks (S53, S54), card icons, reviewed image generation
- New chapter: Spectrum — dispersion + EM spectrum + scattering, with
  dispersion/EM-spectrum/scattering diagrams and Qwen heroes
- icons.py: white-glyph icon set auto-picked by card heading; wired into cards()
- images.py: educational prompt wrapper + vision-model review loop
  (qwen3-vl-plus) that regenerates up to 3x until the image passes review
- Upgraded existing quizzes to moderate, application-level questions
- Rebuilt all Grade-10 decks with icons + mirrored quiz design

Co-Authored-By: Claude Opus 4.8 <noreply@anthropic.com>
Claude-Session: https://claude.ai/code/session_01CMf3jxiAmmK8EhFYBpiUnk
</commit_message>
<xml_diff>
--- a/ppt/Grade10/G10_S34_Refraction_at_Plane_Surfaces_1.pptx
+++ b/ppt/Grade10/G10_S34_Refraction_at_Plane_Surfaces_1.pptx
@@ -6469,7 +6469,7 @@
                 </a:solidFill>
                 <a:latin typeface="Calibri"/>
               </a:rPr>
-              <a:t>Quick Check — The Basics</a:t>
+              <a:t>Check Your Understanding</a:t>
             </a:r>
           </a:p>
         </p:txBody>
@@ -6688,7 +6688,7 @@
                 </a:solidFill>
                 <a:latin typeface="Calibri"/>
               </a:rPr>
-              <a:t>Q1 — Bending</a:t>
+              <a:t>Q1 — Crossing a Boundary</a:t>
             </a:r>
           </a:p>
         </p:txBody>
@@ -6775,7 +6775,7 @@
                 </a:solidFill>
                 <a:latin typeface="Calibri"/>
               </a:rPr>
-              <a:t>Light passes from air into glass. The refracted ray bends:</a:t>
+              <a:t>A ray of light passes from water (n = 1.33) into glass (n = 1.5). On entering the glass the ray will:</a:t>
             </a:r>
           </a:p>
         </p:txBody>
@@ -6935,7 +6935,7 @@
                 </a:solidFill>
                 <a:latin typeface="Calibri"/>
               </a:rPr>
-              <a:t>Away from the normal</a:t>
+              <a:t>Bend toward the normal and slow down</a:t>
             </a:r>
           </a:p>
         </p:txBody>
@@ -7095,7 +7095,7 @@
                 </a:solidFill>
                 <a:latin typeface="Calibri"/>
               </a:rPr>
-              <a:t>Toward the normal</a:t>
+              <a:t>Bend away from the normal and speed up</a:t>
             </a:r>
           </a:p>
         </p:txBody>
@@ -7255,7 +7255,7 @@
                 </a:solidFill>
                 <a:latin typeface="Calibri"/>
               </a:rPr>
-              <a:t>Along the surface</a:t>
+              <a:t>Go straight through without bending</a:t>
             </a:r>
           </a:p>
         </p:txBody>
@@ -7415,7 +7415,7 @@
                 </a:solidFill>
                 <a:latin typeface="Calibri"/>
               </a:rPr>
-              <a:t>It does not bend</a:t>
+              <a:t>Bend toward the normal and speed up</a:t>
             </a:r>
           </a:p>
         </p:txBody>
@@ -7599,7 +7599,7 @@
                 </a:solidFill>
                 <a:latin typeface="Calibri"/>
               </a:rPr>
-              <a:t>Q1 — Bending</a:t>
+              <a:t>Q1 — Crossing a Boundary</a:t>
             </a:r>
           </a:p>
         </p:txBody>
@@ -7686,7 +7686,7 @@
                 </a:solidFill>
                 <a:latin typeface="Calibri"/>
               </a:rPr>
-              <a:t>Light passes from air into glass. The refracted ray bends:</a:t>
+              <a:t>A ray of light passes from water (n = 1.33) into glass (n = 1.5). On entering the glass the ray will:</a:t>
             </a:r>
           </a:p>
         </p:txBody>
@@ -7700,166 +7700,6 @@
         <p:spPr>
           <a:xfrm>
             <a:off x="640080" y="3337560"/>
-            <a:ext cx="5349240" cy="868680"/>
-          </a:xfrm>
-          <a:prstGeom prst="roundRect">
-            <a:avLst>
-              <a:gd name="adj" fmla="val 12000"/>
-            </a:avLst>
-          </a:prstGeom>
-          <a:solidFill>
-            <a:srgbClr val="EAF1F4"/>
-          </a:solidFill>
-          <a:ln>
-            <a:noFill/>
-          </a:ln>
-          <a:effectLst/>
-        </p:spPr>
-        <p:style>
-          <a:lnRef idx="1">
-            <a:schemeClr val="accent1"/>
-          </a:lnRef>
-          <a:fillRef idx="3">
-            <a:schemeClr val="accent1"/>
-          </a:fillRef>
-          <a:effectRef idx="2">
-            <a:schemeClr val="accent1"/>
-          </a:effectRef>
-          <a:fontRef idx="minor">
-            <a:schemeClr val="lt1"/>
-          </a:fontRef>
-        </p:style>
-        <p:txBody>
-          <a:bodyPr rtlCol="0" anchor="ctr"/>
-          <a:lstStyle/>
-          <a:p>
-            <a:pPr algn="ctr"/>
-          </a:p>
-        </p:txBody>
-      </p:sp>
-      <p:sp>
-        <p:nvSpPr>
-          <p:cNvPr id="9" name="Oval 8"/>
-          <p:cNvSpPr/>
-          <p:nvPr/>
-        </p:nvSpPr>
-        <p:spPr>
-          <a:xfrm>
-            <a:off x="914400" y="3566160"/>
-            <a:ext cx="411480" cy="411480"/>
-          </a:xfrm>
-          <a:prstGeom prst="ellipse">
-            <a:avLst/>
-          </a:prstGeom>
-          <a:solidFill>
-            <a:srgbClr val="B7C2CC"/>
-          </a:solidFill>
-          <a:ln>
-            <a:noFill/>
-          </a:ln>
-          <a:effectLst/>
-        </p:spPr>
-        <p:style>
-          <a:lnRef idx="1">
-            <a:schemeClr val="accent1"/>
-          </a:lnRef>
-          <a:fillRef idx="3">
-            <a:schemeClr val="accent1"/>
-          </a:fillRef>
-          <a:effectRef idx="2">
-            <a:schemeClr val="accent1"/>
-          </a:effectRef>
-          <a:fontRef idx="minor">
-            <a:schemeClr val="lt1"/>
-          </a:fontRef>
-        </p:style>
-        <p:txBody>
-          <a:bodyPr rtlCol="0" anchor="ctr"/>
-          <a:lstStyle/>
-          <a:p>
-            <a:pPr algn="ctr"/>
-          </a:p>
-        </p:txBody>
-      </p:sp>
-      <p:sp>
-        <p:nvSpPr>
-          <p:cNvPr id="10" name="TextBox 9"/>
-          <p:cNvSpPr txBox="1"/>
-          <p:nvPr/>
-        </p:nvSpPr>
-        <p:spPr>
-          <a:xfrm>
-            <a:off x="914400" y="3566160"/>
-            <a:ext cx="411480" cy="411480"/>
-          </a:xfrm>
-          <a:prstGeom prst="rect">
-            <a:avLst/>
-          </a:prstGeom>
-          <a:noFill/>
-        </p:spPr>
-        <p:txBody>
-          <a:bodyPr wrap="square" anchor="ctr" lIns="0" rIns="0" tIns="0" bIns="0">
-            <a:spAutoFit/>
-          </a:bodyPr>
-          <a:lstStyle/>
-          <a:p>
-            <a:pPr algn="ctr"/>
-            <a:r>
-              <a:rPr sz="1400" b="1" i="0">
-                <a:solidFill>
-                  <a:srgbClr val="FFFFFF"/>
-                </a:solidFill>
-                <a:latin typeface="Calibri"/>
-              </a:rPr>
-              <a:t>A</a:t>
-            </a:r>
-          </a:p>
-        </p:txBody>
-      </p:sp>
-      <p:sp>
-        <p:nvSpPr>
-          <p:cNvPr id="11" name="TextBox 10"/>
-          <p:cNvSpPr txBox="1"/>
-          <p:nvPr/>
-        </p:nvSpPr>
-        <p:spPr>
-          <a:xfrm>
-            <a:off x="1508760" y="3337560"/>
-            <a:ext cx="4297680" cy="868680"/>
-          </a:xfrm>
-          <a:prstGeom prst="rect">
-            <a:avLst/>
-          </a:prstGeom>
-          <a:noFill/>
-        </p:spPr>
-        <p:txBody>
-          <a:bodyPr wrap="square" anchor="ctr" lIns="0" rIns="0" tIns="0" bIns="0">
-            <a:spAutoFit/>
-          </a:bodyPr>
-          <a:lstStyle/>
-          <a:p>
-            <a:pPr algn="l"/>
-            <a:r>
-              <a:rPr sz="1450" b="0" i="0">
-                <a:solidFill>
-                  <a:srgbClr val="6B7280"/>
-                </a:solidFill>
-                <a:latin typeface="Calibri"/>
-              </a:rPr>
-              <a:t>Away from the normal</a:t>
-            </a:r>
-          </a:p>
-        </p:txBody>
-      </p:sp>
-      <p:sp>
-        <p:nvSpPr>
-          <p:cNvPr id="12" name="Rounded Rectangle 11"/>
-          <p:cNvSpPr/>
-          <p:nvPr/>
-        </p:nvSpPr>
-        <p:spPr>
-          <a:xfrm>
-            <a:off x="6172200" y="3337560"/>
             <a:ext cx="5349240" cy="868680"/>
           </a:xfrm>
           <a:prstGeom prst="roundRect">
@@ -7901,13 +7741,13 @@
       </p:sp>
       <p:sp>
         <p:nvSpPr>
-          <p:cNvPr id="13" name="Oval 12"/>
+          <p:cNvPr id="9" name="Oval 8"/>
           <p:cNvSpPr/>
           <p:nvPr/>
         </p:nvSpPr>
         <p:spPr>
           <a:xfrm>
-            <a:off x="6446520" y="3566160"/>
+            <a:off x="914400" y="3566160"/>
             <a:ext cx="411480" cy="411480"/>
           </a:xfrm>
           <a:prstGeom prst="ellipse">
@@ -7945,13 +7785,13 @@
       </p:sp>
       <p:sp>
         <p:nvSpPr>
-          <p:cNvPr id="14" name="TextBox 13"/>
+          <p:cNvPr id="10" name="TextBox 9"/>
           <p:cNvSpPr txBox="1"/>
           <p:nvPr/>
         </p:nvSpPr>
         <p:spPr>
           <a:xfrm>
-            <a:off x="6446520" y="3566160"/>
+            <a:off x="914400" y="3566160"/>
             <a:ext cx="411480" cy="411480"/>
           </a:xfrm>
           <a:prstGeom prst="rect">
@@ -7980,13 +7820,13 @@
       </p:sp>
       <p:sp>
         <p:nvSpPr>
-          <p:cNvPr id="15" name="TextBox 14"/>
+          <p:cNvPr id="11" name="TextBox 10"/>
           <p:cNvSpPr txBox="1"/>
           <p:nvPr/>
         </p:nvSpPr>
         <p:spPr>
           <a:xfrm>
-            <a:off x="7040880" y="3337560"/>
+            <a:off x="1508760" y="3337560"/>
             <a:ext cx="4297680" cy="868680"/>
           </a:xfrm>
           <a:prstGeom prst="rect">
@@ -8008,20 +7848,20 @@
                 </a:solidFill>
                 <a:latin typeface="Calibri"/>
               </a:rPr>
-              <a:t>Toward the normal</a:t>
-            </a:r>
-          </a:p>
-        </p:txBody>
-      </p:sp>
-      <p:sp>
-        <p:nvSpPr>
-          <p:cNvPr id="16" name="Rounded Rectangle 15"/>
+              <a:t>Bend toward the normal and slow down</a:t>
+            </a:r>
+          </a:p>
+        </p:txBody>
+      </p:sp>
+      <p:sp>
+        <p:nvSpPr>
+          <p:cNvPr id="12" name="Rounded Rectangle 11"/>
           <p:cNvSpPr/>
           <p:nvPr/>
         </p:nvSpPr>
         <p:spPr>
           <a:xfrm>
-            <a:off x="640080" y="4370831"/>
+            <a:off x="6172200" y="3337560"/>
             <a:ext cx="5349240" cy="868680"/>
           </a:xfrm>
           <a:prstGeom prst="roundRect">
@@ -8061,13 +7901,13 @@
       </p:sp>
       <p:sp>
         <p:nvSpPr>
-          <p:cNvPr id="17" name="Oval 16"/>
+          <p:cNvPr id="13" name="Oval 12"/>
           <p:cNvSpPr/>
           <p:nvPr/>
         </p:nvSpPr>
         <p:spPr>
           <a:xfrm>
-            <a:off x="914400" y="4599431"/>
+            <a:off x="6446520" y="3566160"/>
             <a:ext cx="411480" cy="411480"/>
           </a:xfrm>
           <a:prstGeom prst="ellipse">
@@ -8105,13 +7945,13 @@
       </p:sp>
       <p:sp>
         <p:nvSpPr>
-          <p:cNvPr id="18" name="TextBox 17"/>
+          <p:cNvPr id="14" name="TextBox 13"/>
           <p:cNvSpPr txBox="1"/>
           <p:nvPr/>
         </p:nvSpPr>
         <p:spPr>
           <a:xfrm>
-            <a:off x="914400" y="4599431"/>
+            <a:off x="6446520" y="3566160"/>
             <a:ext cx="411480" cy="411480"/>
           </a:xfrm>
           <a:prstGeom prst="rect">
@@ -8133,20 +7973,20 @@
                 </a:solidFill>
                 <a:latin typeface="Calibri"/>
               </a:rPr>
-              <a:t>C</a:t>
-            </a:r>
-          </a:p>
-        </p:txBody>
-      </p:sp>
-      <p:sp>
-        <p:nvSpPr>
-          <p:cNvPr id="19" name="TextBox 18"/>
+              <a:t>B</a:t>
+            </a:r>
+          </a:p>
+        </p:txBody>
+      </p:sp>
+      <p:sp>
+        <p:nvSpPr>
+          <p:cNvPr id="15" name="TextBox 14"/>
           <p:cNvSpPr txBox="1"/>
           <p:nvPr/>
         </p:nvSpPr>
         <p:spPr>
           <a:xfrm>
-            <a:off x="1508760" y="4370831"/>
+            <a:off x="7040880" y="3337560"/>
             <a:ext cx="4297680" cy="868680"/>
           </a:xfrm>
           <a:prstGeom prst="rect">
@@ -8168,20 +8008,20 @@
                 </a:solidFill>
                 <a:latin typeface="Calibri"/>
               </a:rPr>
-              <a:t>Along the surface</a:t>
-            </a:r>
-          </a:p>
-        </p:txBody>
-      </p:sp>
-      <p:sp>
-        <p:nvSpPr>
-          <p:cNvPr id="20" name="Rounded Rectangle 19"/>
+              <a:t>Bend away from the normal and speed up</a:t>
+            </a:r>
+          </a:p>
+        </p:txBody>
+      </p:sp>
+      <p:sp>
+        <p:nvSpPr>
+          <p:cNvPr id="16" name="Rounded Rectangle 15"/>
           <p:cNvSpPr/>
           <p:nvPr/>
         </p:nvSpPr>
         <p:spPr>
           <a:xfrm>
-            <a:off x="6172200" y="4370831"/>
+            <a:off x="640080" y="4370831"/>
             <a:ext cx="5349240" cy="868680"/>
           </a:xfrm>
           <a:prstGeom prst="roundRect">
@@ -8221,13 +8061,13 @@
       </p:sp>
       <p:sp>
         <p:nvSpPr>
-          <p:cNvPr id="21" name="Oval 20"/>
+          <p:cNvPr id="17" name="Oval 16"/>
           <p:cNvSpPr/>
           <p:nvPr/>
         </p:nvSpPr>
         <p:spPr>
           <a:xfrm>
-            <a:off x="6446520" y="4599431"/>
+            <a:off x="914400" y="4599431"/>
             <a:ext cx="411480" cy="411480"/>
           </a:xfrm>
           <a:prstGeom prst="ellipse">
@@ -8265,13 +8105,13 @@
       </p:sp>
       <p:sp>
         <p:nvSpPr>
-          <p:cNvPr id="22" name="TextBox 21"/>
+          <p:cNvPr id="18" name="TextBox 17"/>
           <p:cNvSpPr txBox="1"/>
           <p:nvPr/>
         </p:nvSpPr>
         <p:spPr>
           <a:xfrm>
-            <a:off x="6446520" y="4599431"/>
+            <a:off x="914400" y="4599431"/>
             <a:ext cx="411480" cy="411480"/>
           </a:xfrm>
           <a:prstGeom prst="rect">
@@ -8293,20 +8133,20 @@
                 </a:solidFill>
                 <a:latin typeface="Calibri"/>
               </a:rPr>
-              <a:t>D</a:t>
-            </a:r>
-          </a:p>
-        </p:txBody>
-      </p:sp>
-      <p:sp>
-        <p:nvSpPr>
-          <p:cNvPr id="23" name="TextBox 22"/>
+              <a:t>C</a:t>
+            </a:r>
+          </a:p>
+        </p:txBody>
+      </p:sp>
+      <p:sp>
+        <p:nvSpPr>
+          <p:cNvPr id="19" name="TextBox 18"/>
           <p:cNvSpPr txBox="1"/>
           <p:nvPr/>
         </p:nvSpPr>
         <p:spPr>
           <a:xfrm>
-            <a:off x="7040880" y="4370831"/>
+            <a:off x="1508760" y="4370831"/>
             <a:ext cx="4297680" cy="868680"/>
           </a:xfrm>
           <a:prstGeom prst="rect">
@@ -8328,7 +8168,167 @@
                 </a:solidFill>
                 <a:latin typeface="Calibri"/>
               </a:rPr>
-              <a:t>It does not bend</a:t>
+              <a:t>Go straight through without bending</a:t>
+            </a:r>
+          </a:p>
+        </p:txBody>
+      </p:sp>
+      <p:sp>
+        <p:nvSpPr>
+          <p:cNvPr id="20" name="Rounded Rectangle 19"/>
+          <p:cNvSpPr/>
+          <p:nvPr/>
+        </p:nvSpPr>
+        <p:spPr>
+          <a:xfrm>
+            <a:off x="6172200" y="4370831"/>
+            <a:ext cx="5349240" cy="868680"/>
+          </a:xfrm>
+          <a:prstGeom prst="roundRect">
+            <a:avLst>
+              <a:gd name="adj" fmla="val 12000"/>
+            </a:avLst>
+          </a:prstGeom>
+          <a:solidFill>
+            <a:srgbClr val="EAF1F4"/>
+          </a:solidFill>
+          <a:ln>
+            <a:noFill/>
+          </a:ln>
+          <a:effectLst/>
+        </p:spPr>
+        <p:style>
+          <a:lnRef idx="1">
+            <a:schemeClr val="accent1"/>
+          </a:lnRef>
+          <a:fillRef idx="3">
+            <a:schemeClr val="accent1"/>
+          </a:fillRef>
+          <a:effectRef idx="2">
+            <a:schemeClr val="accent1"/>
+          </a:effectRef>
+          <a:fontRef idx="minor">
+            <a:schemeClr val="lt1"/>
+          </a:fontRef>
+        </p:style>
+        <p:txBody>
+          <a:bodyPr rtlCol="0" anchor="ctr"/>
+          <a:lstStyle/>
+          <a:p>
+            <a:pPr algn="ctr"/>
+          </a:p>
+        </p:txBody>
+      </p:sp>
+      <p:sp>
+        <p:nvSpPr>
+          <p:cNvPr id="21" name="Oval 20"/>
+          <p:cNvSpPr/>
+          <p:nvPr/>
+        </p:nvSpPr>
+        <p:spPr>
+          <a:xfrm>
+            <a:off x="6446520" y="4599431"/>
+            <a:ext cx="411480" cy="411480"/>
+          </a:xfrm>
+          <a:prstGeom prst="ellipse">
+            <a:avLst/>
+          </a:prstGeom>
+          <a:solidFill>
+            <a:srgbClr val="B7C2CC"/>
+          </a:solidFill>
+          <a:ln>
+            <a:noFill/>
+          </a:ln>
+          <a:effectLst/>
+        </p:spPr>
+        <p:style>
+          <a:lnRef idx="1">
+            <a:schemeClr val="accent1"/>
+          </a:lnRef>
+          <a:fillRef idx="3">
+            <a:schemeClr val="accent1"/>
+          </a:fillRef>
+          <a:effectRef idx="2">
+            <a:schemeClr val="accent1"/>
+          </a:effectRef>
+          <a:fontRef idx="minor">
+            <a:schemeClr val="lt1"/>
+          </a:fontRef>
+        </p:style>
+        <p:txBody>
+          <a:bodyPr rtlCol="0" anchor="ctr"/>
+          <a:lstStyle/>
+          <a:p>
+            <a:pPr algn="ctr"/>
+          </a:p>
+        </p:txBody>
+      </p:sp>
+      <p:sp>
+        <p:nvSpPr>
+          <p:cNvPr id="22" name="TextBox 21"/>
+          <p:cNvSpPr txBox="1"/>
+          <p:nvPr/>
+        </p:nvSpPr>
+        <p:spPr>
+          <a:xfrm>
+            <a:off x="6446520" y="4599431"/>
+            <a:ext cx="411480" cy="411480"/>
+          </a:xfrm>
+          <a:prstGeom prst="rect">
+            <a:avLst/>
+          </a:prstGeom>
+          <a:noFill/>
+        </p:spPr>
+        <p:txBody>
+          <a:bodyPr wrap="square" anchor="ctr" lIns="0" rIns="0" tIns="0" bIns="0">
+            <a:spAutoFit/>
+          </a:bodyPr>
+          <a:lstStyle/>
+          <a:p>
+            <a:pPr algn="ctr"/>
+            <a:r>
+              <a:rPr sz="1400" b="1" i="0">
+                <a:solidFill>
+                  <a:srgbClr val="FFFFFF"/>
+                </a:solidFill>
+                <a:latin typeface="Calibri"/>
+              </a:rPr>
+              <a:t>D</a:t>
+            </a:r>
+          </a:p>
+        </p:txBody>
+      </p:sp>
+      <p:sp>
+        <p:nvSpPr>
+          <p:cNvPr id="23" name="TextBox 22"/>
+          <p:cNvSpPr txBox="1"/>
+          <p:nvPr/>
+        </p:nvSpPr>
+        <p:spPr>
+          <a:xfrm>
+            <a:off x="7040880" y="4370831"/>
+            <a:ext cx="4297680" cy="868680"/>
+          </a:xfrm>
+          <a:prstGeom prst="rect">
+            <a:avLst/>
+          </a:prstGeom>
+          <a:noFill/>
+        </p:spPr>
+        <p:txBody>
+          <a:bodyPr wrap="square" anchor="ctr" lIns="0" rIns="0" tIns="0" bIns="0">
+            <a:spAutoFit/>
+          </a:bodyPr>
+          <a:lstStyle/>
+          <a:p>
+            <a:pPr algn="l"/>
+            <a:r>
+              <a:rPr sz="1450" b="0" i="0">
+                <a:solidFill>
+                  <a:srgbClr val="6B7280"/>
+                </a:solidFill>
+                <a:latin typeface="Calibri"/>
+              </a:rPr>
+              <a:t>Bend toward the normal and speed up</a:t>
             </a:r>
           </a:p>
         </p:txBody>
@@ -8454,7 +8454,7 @@
                 </a:solidFill>
                 <a:latin typeface="Calibri"/>
               </a:rPr>
-              <a:t>Glass is denser than air, so light slows down and bends toward the normal. Hence the angle of refraction is smaller than the angle of incidence.</a:t>
+              <a:t>Glass is optically denser than water (higher n), so light slows down on entering it and bends toward the normal — even though neither medium is air. Density, not 'air vs glass', decides the direction of bending.</a:t>
             </a:r>
           </a:p>
         </p:txBody>
@@ -8638,7 +8638,7 @@
                 </a:solidFill>
                 <a:latin typeface="Calibri"/>
               </a:rPr>
-              <a:t>Q2 — Refractive Index</a:t>
+              <a:t>Q2 — What Changes?</a:t>
             </a:r>
           </a:p>
         </p:txBody>
@@ -8725,7 +8725,7 @@
                 </a:solidFill>
                 <a:latin typeface="Calibri"/>
               </a:rPr>
-              <a:t>The refractive index of a medium is the ratio of:</a:t>
+              <a:t>When light passes from air into a glass block, which of these does NOT change?</a:t>
             </a:r>
           </a:p>
         </p:txBody>
@@ -8885,7 +8885,7 @@
                 </a:solidFill>
                 <a:latin typeface="Calibri"/>
               </a:rPr>
-              <a:t>v in medium to c in vacuum</a:t>
+              <a:t>Its speed</a:t>
             </a:r>
           </a:p>
         </p:txBody>
@@ -9045,7 +9045,7 @@
                 </a:solidFill>
                 <a:latin typeface="Calibri"/>
               </a:rPr>
-              <a:t>c in vacuum to v in medium</a:t>
+              <a:t>Its wavelength</a:t>
             </a:r>
           </a:p>
         </p:txBody>
@@ -9205,7 +9205,7 @@
                 </a:solidFill>
                 <a:latin typeface="Calibri"/>
               </a:rPr>
-              <a:t>sin r to sin i</a:t>
+              <a:t>Its frequency</a:t>
             </a:r>
           </a:p>
         </p:txBody>
@@ -9365,7 +9365,7 @@
                 </a:solidFill>
                 <a:latin typeface="Calibri"/>
               </a:rPr>
-              <a:t>wavelength to frequency</a:t>
+              <a:t>Its direction</a:t>
             </a:r>
           </a:p>
         </p:txBody>
@@ -9549,7 +9549,7 @@
                 </a:solidFill>
                 <a:latin typeface="Calibri"/>
               </a:rPr>
-              <a:t>Q2 — Refractive Index</a:t>
+              <a:t>Q2 — What Changes?</a:t>
             </a:r>
           </a:p>
         </p:txBody>
@@ -9636,7 +9636,7 @@
                 </a:solidFill>
                 <a:latin typeface="Calibri"/>
               </a:rPr>
-              <a:t>The refractive index of a medium is the ratio of:</a:t>
+              <a:t>When light passes from air into a glass block, which of these does NOT change?</a:t>
             </a:r>
           </a:p>
         </p:txBody>
@@ -9796,7 +9796,7 @@
                 </a:solidFill>
                 <a:latin typeface="Calibri"/>
               </a:rPr>
-              <a:t>v in medium to c in vacuum</a:t>
+              <a:t>Its speed</a:t>
             </a:r>
           </a:p>
         </p:txBody>
@@ -9810,6 +9810,166 @@
         <p:spPr>
           <a:xfrm>
             <a:off x="6172200" y="3337560"/>
+            <a:ext cx="5349240" cy="868680"/>
+          </a:xfrm>
+          <a:prstGeom prst="roundRect">
+            <a:avLst>
+              <a:gd name="adj" fmla="val 12000"/>
+            </a:avLst>
+          </a:prstGeom>
+          <a:solidFill>
+            <a:srgbClr val="EAF1F4"/>
+          </a:solidFill>
+          <a:ln>
+            <a:noFill/>
+          </a:ln>
+          <a:effectLst/>
+        </p:spPr>
+        <p:style>
+          <a:lnRef idx="1">
+            <a:schemeClr val="accent1"/>
+          </a:lnRef>
+          <a:fillRef idx="3">
+            <a:schemeClr val="accent1"/>
+          </a:fillRef>
+          <a:effectRef idx="2">
+            <a:schemeClr val="accent1"/>
+          </a:effectRef>
+          <a:fontRef idx="minor">
+            <a:schemeClr val="lt1"/>
+          </a:fontRef>
+        </p:style>
+        <p:txBody>
+          <a:bodyPr rtlCol="0" anchor="ctr"/>
+          <a:lstStyle/>
+          <a:p>
+            <a:pPr algn="ctr"/>
+          </a:p>
+        </p:txBody>
+      </p:sp>
+      <p:sp>
+        <p:nvSpPr>
+          <p:cNvPr id="13" name="Oval 12"/>
+          <p:cNvSpPr/>
+          <p:nvPr/>
+        </p:nvSpPr>
+        <p:spPr>
+          <a:xfrm>
+            <a:off x="6446520" y="3566160"/>
+            <a:ext cx="411480" cy="411480"/>
+          </a:xfrm>
+          <a:prstGeom prst="ellipse">
+            <a:avLst/>
+          </a:prstGeom>
+          <a:solidFill>
+            <a:srgbClr val="B7C2CC"/>
+          </a:solidFill>
+          <a:ln>
+            <a:noFill/>
+          </a:ln>
+          <a:effectLst/>
+        </p:spPr>
+        <p:style>
+          <a:lnRef idx="1">
+            <a:schemeClr val="accent1"/>
+          </a:lnRef>
+          <a:fillRef idx="3">
+            <a:schemeClr val="accent1"/>
+          </a:fillRef>
+          <a:effectRef idx="2">
+            <a:schemeClr val="accent1"/>
+          </a:effectRef>
+          <a:fontRef idx="minor">
+            <a:schemeClr val="lt1"/>
+          </a:fontRef>
+        </p:style>
+        <p:txBody>
+          <a:bodyPr rtlCol="0" anchor="ctr"/>
+          <a:lstStyle/>
+          <a:p>
+            <a:pPr algn="ctr"/>
+          </a:p>
+        </p:txBody>
+      </p:sp>
+      <p:sp>
+        <p:nvSpPr>
+          <p:cNvPr id="14" name="TextBox 13"/>
+          <p:cNvSpPr txBox="1"/>
+          <p:nvPr/>
+        </p:nvSpPr>
+        <p:spPr>
+          <a:xfrm>
+            <a:off x="6446520" y="3566160"/>
+            <a:ext cx="411480" cy="411480"/>
+          </a:xfrm>
+          <a:prstGeom prst="rect">
+            <a:avLst/>
+          </a:prstGeom>
+          <a:noFill/>
+        </p:spPr>
+        <p:txBody>
+          <a:bodyPr wrap="square" anchor="ctr" lIns="0" rIns="0" tIns="0" bIns="0">
+            <a:spAutoFit/>
+          </a:bodyPr>
+          <a:lstStyle/>
+          <a:p>
+            <a:pPr algn="ctr"/>
+            <a:r>
+              <a:rPr sz="1400" b="1" i="0">
+                <a:solidFill>
+                  <a:srgbClr val="FFFFFF"/>
+                </a:solidFill>
+                <a:latin typeface="Calibri"/>
+              </a:rPr>
+              <a:t>B</a:t>
+            </a:r>
+          </a:p>
+        </p:txBody>
+      </p:sp>
+      <p:sp>
+        <p:nvSpPr>
+          <p:cNvPr id="15" name="TextBox 14"/>
+          <p:cNvSpPr txBox="1"/>
+          <p:nvPr/>
+        </p:nvSpPr>
+        <p:spPr>
+          <a:xfrm>
+            <a:off x="7040880" y="3337560"/>
+            <a:ext cx="4297680" cy="868680"/>
+          </a:xfrm>
+          <a:prstGeom prst="rect">
+            <a:avLst/>
+          </a:prstGeom>
+          <a:noFill/>
+        </p:spPr>
+        <p:txBody>
+          <a:bodyPr wrap="square" anchor="ctr" lIns="0" rIns="0" tIns="0" bIns="0">
+            <a:spAutoFit/>
+          </a:bodyPr>
+          <a:lstStyle/>
+          <a:p>
+            <a:pPr algn="l"/>
+            <a:r>
+              <a:rPr sz="1450" b="0" i="0">
+                <a:solidFill>
+                  <a:srgbClr val="6B7280"/>
+                </a:solidFill>
+                <a:latin typeface="Calibri"/>
+              </a:rPr>
+              <a:t>Its wavelength</a:t>
+            </a:r>
+          </a:p>
+        </p:txBody>
+      </p:sp>
+      <p:sp>
+        <p:nvSpPr>
+          <p:cNvPr id="16" name="Rounded Rectangle 15"/>
+          <p:cNvSpPr/>
+          <p:nvPr/>
+        </p:nvSpPr>
+        <p:spPr>
+          <a:xfrm>
+            <a:off x="640080" y="4370831"/>
             <a:ext cx="5349240" cy="868680"/>
           </a:xfrm>
           <a:prstGeom prst="roundRect">
@@ -9851,13 +10011,13 @@
       </p:sp>
       <p:sp>
         <p:nvSpPr>
-          <p:cNvPr id="13" name="Oval 12"/>
+          <p:cNvPr id="17" name="Oval 16"/>
           <p:cNvSpPr/>
           <p:nvPr/>
         </p:nvSpPr>
         <p:spPr>
           <a:xfrm>
-            <a:off x="6446520" y="3566160"/>
+            <a:off x="914400" y="4599431"/>
             <a:ext cx="411480" cy="411480"/>
           </a:xfrm>
           <a:prstGeom prst="ellipse">
@@ -9895,13 +10055,13 @@
       </p:sp>
       <p:sp>
         <p:nvSpPr>
-          <p:cNvPr id="14" name="TextBox 13"/>
+          <p:cNvPr id="18" name="TextBox 17"/>
           <p:cNvSpPr txBox="1"/>
           <p:nvPr/>
         </p:nvSpPr>
         <p:spPr>
           <a:xfrm>
-            <a:off x="6446520" y="3566160"/>
+            <a:off x="914400" y="4599431"/>
             <a:ext cx="411480" cy="411480"/>
           </a:xfrm>
           <a:prstGeom prst="rect">
@@ -9930,13 +10090,13 @@
       </p:sp>
       <p:sp>
         <p:nvSpPr>
-          <p:cNvPr id="15" name="TextBox 14"/>
+          <p:cNvPr id="19" name="TextBox 18"/>
           <p:cNvSpPr txBox="1"/>
           <p:nvPr/>
         </p:nvSpPr>
         <p:spPr>
           <a:xfrm>
-            <a:off x="7040880" y="3337560"/>
+            <a:off x="1508760" y="4370831"/>
             <a:ext cx="4297680" cy="868680"/>
           </a:xfrm>
           <a:prstGeom prst="rect">
@@ -9958,20 +10118,20 @@
                 </a:solidFill>
                 <a:latin typeface="Calibri"/>
               </a:rPr>
-              <a:t>c in vacuum to v in medium</a:t>
-            </a:r>
-          </a:p>
-        </p:txBody>
-      </p:sp>
-      <p:sp>
-        <p:nvSpPr>
-          <p:cNvPr id="16" name="Rounded Rectangle 15"/>
+              <a:t>Its frequency</a:t>
+            </a:r>
+          </a:p>
+        </p:txBody>
+      </p:sp>
+      <p:sp>
+        <p:nvSpPr>
+          <p:cNvPr id="20" name="Rounded Rectangle 19"/>
           <p:cNvSpPr/>
           <p:nvPr/>
         </p:nvSpPr>
         <p:spPr>
           <a:xfrm>
-            <a:off x="640080" y="4370831"/>
+            <a:off x="6172200" y="4370831"/>
             <a:ext cx="5349240" cy="868680"/>
           </a:xfrm>
           <a:prstGeom prst="roundRect">
@@ -10011,13 +10171,13 @@
       </p:sp>
       <p:sp>
         <p:nvSpPr>
-          <p:cNvPr id="17" name="Oval 16"/>
+          <p:cNvPr id="21" name="Oval 20"/>
           <p:cNvSpPr/>
           <p:nvPr/>
         </p:nvSpPr>
         <p:spPr>
           <a:xfrm>
-            <a:off x="914400" y="4599431"/>
+            <a:off x="6446520" y="4599431"/>
             <a:ext cx="411480" cy="411480"/>
           </a:xfrm>
           <a:prstGeom prst="ellipse">
@@ -10055,13 +10215,13 @@
       </p:sp>
       <p:sp>
         <p:nvSpPr>
-          <p:cNvPr id="18" name="TextBox 17"/>
+          <p:cNvPr id="22" name="TextBox 21"/>
           <p:cNvSpPr txBox="1"/>
           <p:nvPr/>
         </p:nvSpPr>
         <p:spPr>
           <a:xfrm>
-            <a:off x="914400" y="4599431"/>
+            <a:off x="6446520" y="4599431"/>
             <a:ext cx="411480" cy="411480"/>
           </a:xfrm>
           <a:prstGeom prst="rect">
@@ -10083,20 +10243,20 @@
                 </a:solidFill>
                 <a:latin typeface="Calibri"/>
               </a:rPr>
-              <a:t>C</a:t>
-            </a:r>
-          </a:p>
-        </p:txBody>
-      </p:sp>
-      <p:sp>
-        <p:nvSpPr>
-          <p:cNvPr id="19" name="TextBox 18"/>
+              <a:t>D</a:t>
+            </a:r>
+          </a:p>
+        </p:txBody>
+      </p:sp>
+      <p:sp>
+        <p:nvSpPr>
+          <p:cNvPr id="23" name="TextBox 22"/>
           <p:cNvSpPr txBox="1"/>
           <p:nvPr/>
         </p:nvSpPr>
         <p:spPr>
           <a:xfrm>
-            <a:off x="1508760" y="4370831"/>
+            <a:off x="7040880" y="4370831"/>
             <a:ext cx="4297680" cy="868680"/>
           </a:xfrm>
           <a:prstGeom prst="rect">
@@ -10118,167 +10278,7 @@
                 </a:solidFill>
                 <a:latin typeface="Calibri"/>
               </a:rPr>
-              <a:t>sin r to sin i</a:t>
-            </a:r>
-          </a:p>
-        </p:txBody>
-      </p:sp>
-      <p:sp>
-        <p:nvSpPr>
-          <p:cNvPr id="20" name="Rounded Rectangle 19"/>
-          <p:cNvSpPr/>
-          <p:nvPr/>
-        </p:nvSpPr>
-        <p:spPr>
-          <a:xfrm>
-            <a:off x="6172200" y="4370831"/>
-            <a:ext cx="5349240" cy="868680"/>
-          </a:xfrm>
-          <a:prstGeom prst="roundRect">
-            <a:avLst>
-              <a:gd name="adj" fmla="val 12000"/>
-            </a:avLst>
-          </a:prstGeom>
-          <a:solidFill>
-            <a:srgbClr val="EAF1F4"/>
-          </a:solidFill>
-          <a:ln>
-            <a:noFill/>
-          </a:ln>
-          <a:effectLst/>
-        </p:spPr>
-        <p:style>
-          <a:lnRef idx="1">
-            <a:schemeClr val="accent1"/>
-          </a:lnRef>
-          <a:fillRef idx="3">
-            <a:schemeClr val="accent1"/>
-          </a:fillRef>
-          <a:effectRef idx="2">
-            <a:schemeClr val="accent1"/>
-          </a:effectRef>
-          <a:fontRef idx="minor">
-            <a:schemeClr val="lt1"/>
-          </a:fontRef>
-        </p:style>
-        <p:txBody>
-          <a:bodyPr rtlCol="0" anchor="ctr"/>
-          <a:lstStyle/>
-          <a:p>
-            <a:pPr algn="ctr"/>
-          </a:p>
-        </p:txBody>
-      </p:sp>
-      <p:sp>
-        <p:nvSpPr>
-          <p:cNvPr id="21" name="Oval 20"/>
-          <p:cNvSpPr/>
-          <p:nvPr/>
-        </p:nvSpPr>
-        <p:spPr>
-          <a:xfrm>
-            <a:off x="6446520" y="4599431"/>
-            <a:ext cx="411480" cy="411480"/>
-          </a:xfrm>
-          <a:prstGeom prst="ellipse">
-            <a:avLst/>
-          </a:prstGeom>
-          <a:solidFill>
-            <a:srgbClr val="B7C2CC"/>
-          </a:solidFill>
-          <a:ln>
-            <a:noFill/>
-          </a:ln>
-          <a:effectLst/>
-        </p:spPr>
-        <p:style>
-          <a:lnRef idx="1">
-            <a:schemeClr val="accent1"/>
-          </a:lnRef>
-          <a:fillRef idx="3">
-            <a:schemeClr val="accent1"/>
-          </a:fillRef>
-          <a:effectRef idx="2">
-            <a:schemeClr val="accent1"/>
-          </a:effectRef>
-          <a:fontRef idx="minor">
-            <a:schemeClr val="lt1"/>
-          </a:fontRef>
-        </p:style>
-        <p:txBody>
-          <a:bodyPr rtlCol="0" anchor="ctr"/>
-          <a:lstStyle/>
-          <a:p>
-            <a:pPr algn="ctr"/>
-          </a:p>
-        </p:txBody>
-      </p:sp>
-      <p:sp>
-        <p:nvSpPr>
-          <p:cNvPr id="22" name="TextBox 21"/>
-          <p:cNvSpPr txBox="1"/>
-          <p:nvPr/>
-        </p:nvSpPr>
-        <p:spPr>
-          <a:xfrm>
-            <a:off x="6446520" y="4599431"/>
-            <a:ext cx="411480" cy="411480"/>
-          </a:xfrm>
-          <a:prstGeom prst="rect">
-            <a:avLst/>
-          </a:prstGeom>
-          <a:noFill/>
-        </p:spPr>
-        <p:txBody>
-          <a:bodyPr wrap="square" anchor="ctr" lIns="0" rIns="0" tIns="0" bIns="0">
-            <a:spAutoFit/>
-          </a:bodyPr>
-          <a:lstStyle/>
-          <a:p>
-            <a:pPr algn="ctr"/>
-            <a:r>
-              <a:rPr sz="1400" b="1" i="0">
-                <a:solidFill>
-                  <a:srgbClr val="FFFFFF"/>
-                </a:solidFill>
-                <a:latin typeface="Calibri"/>
-              </a:rPr>
-              <a:t>D</a:t>
-            </a:r>
-          </a:p>
-        </p:txBody>
-      </p:sp>
-      <p:sp>
-        <p:nvSpPr>
-          <p:cNvPr id="23" name="TextBox 22"/>
-          <p:cNvSpPr txBox="1"/>
-          <p:nvPr/>
-        </p:nvSpPr>
-        <p:spPr>
-          <a:xfrm>
-            <a:off x="7040880" y="4370831"/>
-            <a:ext cx="4297680" cy="868680"/>
-          </a:xfrm>
-          <a:prstGeom prst="rect">
-            <a:avLst/>
-          </a:prstGeom>
-          <a:noFill/>
-        </p:spPr>
-        <p:txBody>
-          <a:bodyPr wrap="square" anchor="ctr" lIns="0" rIns="0" tIns="0" bIns="0">
-            <a:spAutoFit/>
-          </a:bodyPr>
-          <a:lstStyle/>
-          <a:p>
-            <a:pPr algn="l"/>
-            <a:r>
-              <a:rPr sz="1450" b="0" i="0">
-                <a:solidFill>
-                  <a:srgbClr val="6B7280"/>
-                </a:solidFill>
-                <a:latin typeface="Calibri"/>
-              </a:rPr>
-              <a:t>wavelength to frequency</a:t>
+              <a:t>Its direction</a:t>
             </a:r>
           </a:p>
         </p:txBody>
@@ -10404,7 +10404,7 @@
                 </a:solidFill>
                 <a:latin typeface="Calibri"/>
               </a:rPr>
-              <a:t>n = c / v. Because v is always less than c in a real medium, n is always greater than 1. It is a pure ratio, so it has no unit.</a:t>
+              <a:t>Inside the glass the light slows down and its wavelength shortens, and at the surface its direction changes. Only the frequency (set by the source) stays the same — a common exam trap.</a:t>
             </a:r>
           </a:p>
         </p:txBody>
@@ -10588,7 +10588,7 @@
                 </a:solidFill>
                 <a:latin typeface="Calibri"/>
               </a:rPr>
-              <a:t>Q3 — Snell's Law</a:t>
+              <a:t>Q3 — Comparing Media</a:t>
             </a:r>
           </a:p>
         </p:txBody>
@@ -10675,7 +10675,7 @@
                 </a:solidFill>
                 <a:latin typeface="Calibri"/>
               </a:rPr>
-              <a:t>In Snell's law, the angles i and r are always measured from the:</a:t>
+              <a:t>Light travels fastest in the medium with the:</a:t>
             </a:r>
           </a:p>
         </p:txBody>
@@ -10835,7 +10835,7 @@
                 </a:solidFill>
                 <a:latin typeface="Calibri"/>
               </a:rPr>
-              <a:t>Surface of the medium</a:t>
+              <a:t>Highest refractive index</a:t>
             </a:r>
           </a:p>
         </p:txBody>
@@ -10995,7 +10995,7 @@
                 </a:solidFill>
                 <a:latin typeface="Calibri"/>
               </a:rPr>
-              <a:t>Normal</a:t>
+              <a:t>Lowest refractive index</a:t>
             </a:r>
           </a:p>
         </p:txBody>
@@ -11155,7 +11155,7 @@
                 </a:solidFill>
                 <a:latin typeface="Calibri"/>
               </a:rPr>
-              <a:t>Refracted ray</a:t>
+              <a:t>Largest angle of refraction</a:t>
             </a:r>
           </a:p>
         </p:txBody>
@@ -11315,7 +11315,7 @@
                 </a:solidFill>
                 <a:latin typeface="Calibri"/>
               </a:rPr>
-              <a:t>Horizontal</a:t>
+              <a:t>Greatest density</a:t>
             </a:r>
           </a:p>
         </p:txBody>
@@ -11499,7 +11499,7 @@
                 </a:solidFill>
                 <a:latin typeface="Calibri"/>
               </a:rPr>
-              <a:t>Q3 — Snell's Law</a:t>
+              <a:t>Q3 — Comparing Media</a:t>
             </a:r>
           </a:p>
         </p:txBody>
@@ -11586,7 +11586,7 @@
                 </a:solidFill>
                 <a:latin typeface="Calibri"/>
               </a:rPr>
-              <a:t>In Snell's law, the angles i and r are always measured from the:</a:t>
+              <a:t>Light travels fastest in the medium with the:</a:t>
             </a:r>
           </a:p>
         </p:txBody>
@@ -11746,7 +11746,7 @@
                 </a:solidFill>
                 <a:latin typeface="Calibri"/>
               </a:rPr>
-              <a:t>Surface of the medium</a:t>
+              <a:t>Highest refractive index</a:t>
             </a:r>
           </a:p>
         </p:txBody>
@@ -11908,7 +11908,7 @@
                 </a:solidFill>
                 <a:latin typeface="Calibri"/>
               </a:rPr>
-              <a:t>Normal</a:t>
+              <a:t>Lowest refractive index</a:t>
             </a:r>
           </a:p>
         </p:txBody>
@@ -12068,7 +12068,7 @@
                 </a:solidFill>
                 <a:latin typeface="Calibri"/>
               </a:rPr>
-              <a:t>Refracted ray</a:t>
+              <a:t>Largest angle of refraction</a:t>
             </a:r>
           </a:p>
         </p:txBody>
@@ -12228,7 +12228,7 @@
                 </a:solidFill>
                 <a:latin typeface="Calibri"/>
               </a:rPr>
-              <a:t>Horizontal</a:t>
+              <a:t>Greatest density</a:t>
             </a:r>
           </a:p>
         </p:txBody>
@@ -12354,7 +12354,7 @@
                 </a:solidFill>
                 <a:latin typeface="Calibri"/>
               </a:rPr>
-              <a:t>Both the angle of incidence and the angle of refraction are measured between the ray and the normal at the point of incidence — never from the surface.</a:t>
+              <a:t>Since n = c/v, a smaller n means a larger speed v. So light is fastest in the optically rarest medium (lowest n) — for example it travels faster in water than in diamond.</a:t>
             </a:r>
           </a:p>
         </p:txBody>
@@ -14496,9 +14496,33 @@
           </a:p>
         </p:txBody>
       </p:sp>
-      <p:sp>
-        <p:nvSpPr>
-          <p:cNvPr id="8" name="TextBox 7"/>
+      <p:pic>
+        <p:nvPicPr>
+          <p:cNvPr id="8" name="Picture 7" descr="spark_FFFFFF.png"/>
+          <p:cNvPicPr>
+            <a:picLocks noChangeAspect="1"/>
+          </p:cNvPicPr>
+          <p:nvPr/>
+        </p:nvPicPr>
+        <p:blipFill>
+          <a:blip r:embed="rId2"/>
+          <a:stretch>
+            <a:fillRect/>
+          </a:stretch>
+        </p:blipFill>
+        <p:spPr>
+          <a:xfrm>
+            <a:off x="1070762" y="2323490"/>
+            <a:ext cx="281635" cy="281635"/>
+          </a:xfrm>
+          <a:prstGeom prst="rect">
+            <a:avLst/>
+          </a:prstGeom>
+        </p:spPr>
+      </p:pic>
+      <p:sp>
+        <p:nvSpPr>
+          <p:cNvPr id="9" name="TextBox 8"/>
           <p:cNvSpPr txBox="1"/>
           <p:nvPr/>
         </p:nvSpPr>
@@ -14533,7 +14557,7 @@
       </p:sp>
       <p:sp>
         <p:nvSpPr>
-          <p:cNvPr id="9" name="TextBox 8"/>
+          <p:cNvPr id="10" name="TextBox 9"/>
           <p:cNvSpPr txBox="1"/>
           <p:nvPr/>
         </p:nvSpPr>
@@ -14568,7 +14592,7 @@
       </p:sp>
       <p:sp>
         <p:nvSpPr>
-          <p:cNvPr id="10" name="Rounded Rectangle 9"/>
+          <p:cNvPr id="11" name="Rounded Rectangle 10"/>
           <p:cNvSpPr/>
           <p:nvPr/>
         </p:nvSpPr>
@@ -14620,7 +14644,7 @@
       </p:sp>
       <p:sp>
         <p:nvSpPr>
-          <p:cNvPr id="11" name="Rounded Rectangle 10"/>
+          <p:cNvPr id="12" name="Rounded Rectangle 11"/>
           <p:cNvSpPr/>
           <p:nvPr/>
         </p:nvSpPr>
@@ -14664,9 +14688,33 @@
           </a:p>
         </p:txBody>
       </p:sp>
-      <p:sp>
-        <p:nvSpPr>
-          <p:cNvPr id="12" name="TextBox 11"/>
+      <p:pic>
+        <p:nvPicPr>
+          <p:cNvPr id="13" name="Picture 12" descr="spark_FFFFFF.png"/>
+          <p:cNvPicPr>
+            <a:picLocks noChangeAspect="1"/>
+          </p:cNvPicPr>
+          <p:nvPr/>
+        </p:nvPicPr>
+        <p:blipFill>
+          <a:blip r:embed="rId2"/>
+          <a:stretch>
+            <a:fillRect/>
+          </a:stretch>
+        </p:blipFill>
+        <p:spPr>
+          <a:xfrm>
+            <a:off x="6648602" y="2323490"/>
+            <a:ext cx="281635" cy="281635"/>
+          </a:xfrm>
+          <a:prstGeom prst="rect">
+            <a:avLst/>
+          </a:prstGeom>
+        </p:spPr>
+      </p:pic>
+      <p:sp>
+        <p:nvSpPr>
+          <p:cNvPr id="14" name="TextBox 13"/>
           <p:cNvSpPr txBox="1"/>
           <p:nvPr/>
         </p:nvSpPr>
@@ -14701,7 +14749,7 @@
       </p:sp>
       <p:sp>
         <p:nvSpPr>
-          <p:cNvPr id="13" name="TextBox 12"/>
+          <p:cNvPr id="15" name="TextBox 14"/>
           <p:cNvSpPr txBox="1"/>
           <p:nvPr/>
         </p:nvSpPr>
@@ -14736,7 +14784,7 @@
       </p:sp>
       <p:sp>
         <p:nvSpPr>
-          <p:cNvPr id="14" name="Rounded Rectangle 13"/>
+          <p:cNvPr id="16" name="Rounded Rectangle 15"/>
           <p:cNvSpPr/>
           <p:nvPr/>
         </p:nvSpPr>
@@ -14788,7 +14836,7 @@
       </p:sp>
       <p:sp>
         <p:nvSpPr>
-          <p:cNvPr id="15" name="Rounded Rectangle 14"/>
+          <p:cNvPr id="17" name="Rounded Rectangle 16"/>
           <p:cNvSpPr/>
           <p:nvPr/>
         </p:nvSpPr>
@@ -14832,9 +14880,33 @@
           </a:p>
         </p:txBody>
       </p:sp>
-      <p:sp>
-        <p:nvSpPr>
-          <p:cNvPr id="16" name="TextBox 15"/>
+      <p:pic>
+        <p:nvPicPr>
+          <p:cNvPr id="18" name="Picture 17" descr="ray_FFFFFF.png"/>
+          <p:cNvPicPr>
+            <a:picLocks noChangeAspect="1"/>
+          </p:cNvPicPr>
+          <p:nvPr/>
+        </p:nvPicPr>
+        <p:blipFill>
+          <a:blip r:embed="rId3"/>
+          <a:stretch>
+            <a:fillRect/>
+          </a:stretch>
+        </p:blipFill>
+        <p:spPr>
+          <a:xfrm>
+            <a:off x="1070762" y="4152290"/>
+            <a:ext cx="281635" cy="281635"/>
+          </a:xfrm>
+          <a:prstGeom prst="rect">
+            <a:avLst/>
+          </a:prstGeom>
+        </p:spPr>
+      </p:pic>
+      <p:sp>
+        <p:nvSpPr>
+          <p:cNvPr id="19" name="TextBox 18"/>
           <p:cNvSpPr txBox="1"/>
           <p:nvPr/>
         </p:nvSpPr>
@@ -14869,7 +14941,7 @@
       </p:sp>
       <p:sp>
         <p:nvSpPr>
-          <p:cNvPr id="17" name="TextBox 16"/>
+          <p:cNvPr id="20" name="TextBox 19"/>
           <p:cNvSpPr txBox="1"/>
           <p:nvPr/>
         </p:nvSpPr>
@@ -14904,7 +14976,7 @@
       </p:sp>
       <p:sp>
         <p:nvSpPr>
-          <p:cNvPr id="18" name="Rounded Rectangle 17"/>
+          <p:cNvPr id="21" name="Rounded Rectangle 20"/>
           <p:cNvSpPr/>
           <p:nvPr/>
         </p:nvSpPr>
@@ -14956,7 +15028,7 @@
       </p:sp>
       <p:sp>
         <p:nvSpPr>
-          <p:cNvPr id="19" name="Rounded Rectangle 18"/>
+          <p:cNvPr id="22" name="Rounded Rectangle 21"/>
           <p:cNvSpPr/>
           <p:nvPr/>
         </p:nvSpPr>
@@ -15000,9 +15072,33 @@
           </a:p>
         </p:txBody>
       </p:sp>
-      <p:sp>
-        <p:nvSpPr>
-          <p:cNvPr id="20" name="TextBox 19"/>
+      <p:pic>
+        <p:nvPicPr>
+          <p:cNvPr id="23" name="Picture 22" descr="spark_FFFFFF.png"/>
+          <p:cNvPicPr>
+            <a:picLocks noChangeAspect="1"/>
+          </p:cNvPicPr>
+          <p:nvPr/>
+        </p:nvPicPr>
+        <p:blipFill>
+          <a:blip r:embed="rId2"/>
+          <a:stretch>
+            <a:fillRect/>
+          </a:stretch>
+        </p:blipFill>
+        <p:spPr>
+          <a:xfrm>
+            <a:off x="6648602" y="4152290"/>
+            <a:ext cx="281635" cy="281635"/>
+          </a:xfrm>
+          <a:prstGeom prst="rect">
+            <a:avLst/>
+          </a:prstGeom>
+        </p:spPr>
+      </p:pic>
+      <p:sp>
+        <p:nvSpPr>
+          <p:cNvPr id="24" name="TextBox 23"/>
           <p:cNvSpPr txBox="1"/>
           <p:nvPr/>
         </p:nvSpPr>
@@ -15037,7 +15133,7 @@
       </p:sp>
       <p:sp>
         <p:nvSpPr>
-          <p:cNvPr id="21" name="TextBox 20"/>
+          <p:cNvPr id="25" name="TextBox 24"/>
           <p:cNvSpPr txBox="1"/>
           <p:nvPr/>
         </p:nvSpPr>
@@ -16228,9 +16324,33 @@
           </a:p>
         </p:txBody>
       </p:sp>
-      <p:sp>
-        <p:nvSpPr>
-          <p:cNvPr id="8" name="TextBox 7"/>
+      <p:pic>
+        <p:nvPicPr>
+          <p:cNvPr id="8" name="Picture 7" descr="spark_FFFFFF.png"/>
+          <p:cNvPicPr>
+            <a:picLocks noChangeAspect="1"/>
+          </p:cNvPicPr>
+          <p:nvPr/>
+        </p:nvPicPr>
+        <p:blipFill>
+          <a:blip r:embed="rId2"/>
+          <a:stretch>
+            <a:fillRect/>
+          </a:stretch>
+        </p:blipFill>
+        <p:spPr>
+          <a:xfrm>
+            <a:off x="1070762" y="2323490"/>
+            <a:ext cx="281635" cy="281635"/>
+          </a:xfrm>
+          <a:prstGeom prst="rect">
+            <a:avLst/>
+          </a:prstGeom>
+        </p:spPr>
+      </p:pic>
+      <p:sp>
+        <p:nvSpPr>
+          <p:cNvPr id="9" name="TextBox 8"/>
           <p:cNvSpPr txBox="1"/>
           <p:nvPr/>
         </p:nvSpPr>
@@ -16265,7 +16385,7 @@
       </p:sp>
       <p:sp>
         <p:nvSpPr>
-          <p:cNvPr id="9" name="TextBox 8"/>
+          <p:cNvPr id="10" name="TextBox 9"/>
           <p:cNvSpPr txBox="1"/>
           <p:nvPr/>
         </p:nvSpPr>
@@ -16300,7 +16420,7 @@
       </p:sp>
       <p:sp>
         <p:nvSpPr>
-          <p:cNvPr id="10" name="Rounded Rectangle 9"/>
+          <p:cNvPr id="11" name="Rounded Rectangle 10"/>
           <p:cNvSpPr/>
           <p:nvPr/>
         </p:nvSpPr>
@@ -16352,7 +16472,7 @@
       </p:sp>
       <p:sp>
         <p:nvSpPr>
-          <p:cNvPr id="11" name="Rounded Rectangle 10"/>
+          <p:cNvPr id="12" name="Rounded Rectangle 11"/>
           <p:cNvSpPr/>
           <p:nvPr/>
         </p:nvSpPr>
@@ -16396,9 +16516,33 @@
           </a:p>
         </p:txBody>
       </p:sp>
-      <p:sp>
-        <p:nvSpPr>
-          <p:cNvPr id="12" name="TextBox 11"/>
+      <p:pic>
+        <p:nvPicPr>
+          <p:cNvPr id="13" name="Picture 12" descr="spark_FFFFFF.png"/>
+          <p:cNvPicPr>
+            <a:picLocks noChangeAspect="1"/>
+          </p:cNvPicPr>
+          <p:nvPr/>
+        </p:nvPicPr>
+        <p:blipFill>
+          <a:blip r:embed="rId2"/>
+          <a:stretch>
+            <a:fillRect/>
+          </a:stretch>
+        </p:blipFill>
+        <p:spPr>
+          <a:xfrm>
+            <a:off x="6648602" y="2323490"/>
+            <a:ext cx="281635" cy="281635"/>
+          </a:xfrm>
+          <a:prstGeom prst="rect">
+            <a:avLst/>
+          </a:prstGeom>
+        </p:spPr>
+      </p:pic>
+      <p:sp>
+        <p:nvSpPr>
+          <p:cNvPr id="14" name="TextBox 13"/>
           <p:cNvSpPr txBox="1"/>
           <p:nvPr/>
         </p:nvSpPr>
@@ -16433,7 +16577,7 @@
       </p:sp>
       <p:sp>
         <p:nvSpPr>
-          <p:cNvPr id="13" name="TextBox 12"/>
+          <p:cNvPr id="15" name="TextBox 14"/>
           <p:cNvSpPr txBox="1"/>
           <p:nvPr/>
         </p:nvSpPr>
@@ -16468,7 +16612,7 @@
       </p:sp>
       <p:sp>
         <p:nvSpPr>
-          <p:cNvPr id="14" name="Rounded Rectangle 13"/>
+          <p:cNvPr id="16" name="Rounded Rectangle 15"/>
           <p:cNvSpPr/>
           <p:nvPr/>
         </p:nvSpPr>
@@ -16520,7 +16664,7 @@
       </p:sp>
       <p:sp>
         <p:nvSpPr>
-          <p:cNvPr id="15" name="Rounded Rectangle 14"/>
+          <p:cNvPr id="17" name="Rounded Rectangle 16"/>
           <p:cNvSpPr/>
           <p:nvPr/>
         </p:nvSpPr>
@@ -16564,9 +16708,33 @@
           </a:p>
         </p:txBody>
       </p:sp>
-      <p:sp>
-        <p:nvSpPr>
-          <p:cNvPr id="16" name="TextBox 15"/>
+      <p:pic>
+        <p:nvPicPr>
+          <p:cNvPr id="18" name="Picture 17" descr="spark_FFFFFF.png"/>
+          <p:cNvPicPr>
+            <a:picLocks noChangeAspect="1"/>
+          </p:cNvPicPr>
+          <p:nvPr/>
+        </p:nvPicPr>
+        <p:blipFill>
+          <a:blip r:embed="rId2"/>
+          <a:stretch>
+            <a:fillRect/>
+          </a:stretch>
+        </p:blipFill>
+        <p:spPr>
+          <a:xfrm>
+            <a:off x="1070762" y="4152290"/>
+            <a:ext cx="281635" cy="281635"/>
+          </a:xfrm>
+          <a:prstGeom prst="rect">
+            <a:avLst/>
+          </a:prstGeom>
+        </p:spPr>
+      </p:pic>
+      <p:sp>
+        <p:nvSpPr>
+          <p:cNvPr id="19" name="TextBox 18"/>
           <p:cNvSpPr txBox="1"/>
           <p:nvPr/>
         </p:nvSpPr>
@@ -16601,7 +16769,7 @@
       </p:sp>
       <p:sp>
         <p:nvSpPr>
-          <p:cNvPr id="17" name="TextBox 16"/>
+          <p:cNvPr id="20" name="TextBox 19"/>
           <p:cNvSpPr txBox="1"/>
           <p:nvPr/>
         </p:nvSpPr>
@@ -16636,7 +16804,7 @@
       </p:sp>
       <p:sp>
         <p:nvSpPr>
-          <p:cNvPr id="18" name="Rounded Rectangle 17"/>
+          <p:cNvPr id="21" name="Rounded Rectangle 20"/>
           <p:cNvSpPr/>
           <p:nvPr/>
         </p:nvSpPr>
@@ -16688,7 +16856,7 @@
       </p:sp>
       <p:sp>
         <p:nvSpPr>
-          <p:cNvPr id="19" name="Rounded Rectangle 18"/>
+          <p:cNvPr id="22" name="Rounded Rectangle 21"/>
           <p:cNvSpPr/>
           <p:nvPr/>
         </p:nvSpPr>
@@ -16732,9 +16900,33 @@
           </a:p>
         </p:txBody>
       </p:sp>
-      <p:sp>
-        <p:nvSpPr>
-          <p:cNvPr id="20" name="TextBox 19"/>
+      <p:pic>
+        <p:nvPicPr>
+          <p:cNvPr id="23" name="Picture 22" descr="lens_FFFFFF.png"/>
+          <p:cNvPicPr>
+            <a:picLocks noChangeAspect="1"/>
+          </p:cNvPicPr>
+          <p:nvPr/>
+        </p:nvPicPr>
+        <p:blipFill>
+          <a:blip r:embed="rId3"/>
+          <a:stretch>
+            <a:fillRect/>
+          </a:stretch>
+        </p:blipFill>
+        <p:spPr>
+          <a:xfrm>
+            <a:off x="6648602" y="4152290"/>
+            <a:ext cx="281635" cy="281635"/>
+          </a:xfrm>
+          <a:prstGeom prst="rect">
+            <a:avLst/>
+          </a:prstGeom>
+        </p:spPr>
+      </p:pic>
+      <p:sp>
+        <p:nvSpPr>
+          <p:cNvPr id="24" name="TextBox 23"/>
           <p:cNvSpPr txBox="1"/>
           <p:nvPr/>
         </p:nvSpPr>
@@ -16769,7 +16961,7 @@
       </p:sp>
       <p:sp>
         <p:nvSpPr>
-          <p:cNvPr id="21" name="TextBox 20"/>
+          <p:cNvPr id="25" name="TextBox 24"/>
           <p:cNvSpPr txBox="1"/>
           <p:nvPr/>
         </p:nvSpPr>
@@ -18220,7 +18412,7 @@
                 </a:solidFill>
                 <a:latin typeface="Calibri"/>
               </a:rPr>
-              <a:t>After passing through a rectangular glass block, the emergent ray is:</a:t>
+              <a:t>A ray enters a rectangular glass slab at an angle of incidence of 50°. What is the angle of emergence as it leaves the opposite, parallel face?</a:t>
             </a:r>
           </a:p>
         </p:txBody>
@@ -18380,7 +18572,7 @@
                 </a:solidFill>
                 <a:latin typeface="Calibri"/>
               </a:rPr>
-              <a:t>Bent toward the normal</a:t>
+              <a:t>Less than 50°</a:t>
             </a:r>
           </a:p>
         </p:txBody>
@@ -18540,7 +18732,7 @@
                 </a:solidFill>
                 <a:latin typeface="Calibri"/>
               </a:rPr>
-              <a:t>Parallel to the incident ray but shifted</a:t>
+              <a:t>Exactly 50°</a:t>
             </a:r>
           </a:p>
         </p:txBody>
@@ -18700,7 +18892,7 @@
                 </a:solidFill>
                 <a:latin typeface="Calibri"/>
               </a:rPr>
-              <a:t>Perpendicular to the incident ray</a:t>
+              <a:t>More than 50°</a:t>
             </a:r>
           </a:p>
         </p:txBody>
@@ -18860,7 +19052,7 @@
                 </a:solidFill>
                 <a:latin typeface="Calibri"/>
               </a:rPr>
-              <a:t>Turned back on itself</a:t>
+              <a:t>It depends on the glass thickness</a:t>
             </a:r>
           </a:p>
         </p:txBody>
@@ -19341,7 +19533,7 @@
                 </a:solidFill>
                 <a:latin typeface="Calibri"/>
               </a:rPr>
-              <a:t>After passing through a rectangular glass block, the emergent ray is:</a:t>
+              <a:t>A ray enters a rectangular glass slab at an angle of incidence of 50°. What is the angle of emergence as it leaves the opposite, parallel face?</a:t>
             </a:r>
           </a:p>
         </p:txBody>
@@ -19501,7 +19693,7 @@
                 </a:solidFill>
                 <a:latin typeface="Calibri"/>
               </a:rPr>
-              <a:t>Bent toward the normal</a:t>
+              <a:t>Less than 50°</a:t>
             </a:r>
           </a:p>
         </p:txBody>
@@ -19663,7 +19855,7 @@
                 </a:solidFill>
                 <a:latin typeface="Calibri"/>
               </a:rPr>
-              <a:t>Parallel to the incident ray but shifted</a:t>
+              <a:t>Exactly 50°</a:t>
             </a:r>
           </a:p>
         </p:txBody>
@@ -19823,7 +20015,7 @@
                 </a:solidFill>
                 <a:latin typeface="Calibri"/>
               </a:rPr>
-              <a:t>Perpendicular to the incident ray</a:t>
+              <a:t>More than 50°</a:t>
             </a:r>
           </a:p>
         </p:txBody>
@@ -19983,7 +20175,7 @@
                 </a:solidFill>
                 <a:latin typeface="Calibri"/>
               </a:rPr>
-              <a:t>Turned back on itself</a:t>
+              <a:t>It depends on the glass thickness</a:t>
             </a:r>
           </a:p>
         </p:txBody>
@@ -20109,7 +20301,7 @@
                 </a:solidFill>
                 <a:latin typeface="Calibri"/>
               </a:rPr>
-              <a:t>The two faces of the block are parallel, so the emergent ray is parallel to the incident ray. It is only displaced sideways by the lateral shift.</a:t>
+              <a:t>Because the two faces are parallel, the bending on entering is exactly undone on leaving. The angle of emergence equals the angle of incidence (50°); the ray is only shifted sideways, not rotated. Thickness changes the shift, not the angle.</a:t>
             </a:r>
           </a:p>
         </p:txBody>
@@ -26895,9 +27087,33 @@
           </a:p>
         </p:txBody>
       </p:sp>
-      <p:sp>
-        <p:nvSpPr>
-          <p:cNvPr id="8" name="TextBox 7"/>
+      <p:pic>
+        <p:nvPicPr>
+          <p:cNvPr id="8" name="Picture 7" descr="spark_FFFFFF.png"/>
+          <p:cNvPicPr>
+            <a:picLocks noChangeAspect="1"/>
+          </p:cNvPicPr>
+          <p:nvPr/>
+        </p:nvPicPr>
+        <p:blipFill>
+          <a:blip r:embed="rId2"/>
+          <a:stretch>
+            <a:fillRect/>
+          </a:stretch>
+        </p:blipFill>
+        <p:spPr>
+          <a:xfrm>
+            <a:off x="1070762" y="2323490"/>
+            <a:ext cx="281635" cy="281635"/>
+          </a:xfrm>
+          <a:prstGeom prst="rect">
+            <a:avLst/>
+          </a:prstGeom>
+        </p:spPr>
+      </p:pic>
+      <p:sp>
+        <p:nvSpPr>
+          <p:cNvPr id="9" name="TextBox 8"/>
           <p:cNvSpPr txBox="1"/>
           <p:nvPr/>
         </p:nvSpPr>
@@ -26932,7 +27148,7 @@
       </p:sp>
       <p:sp>
         <p:nvSpPr>
-          <p:cNvPr id="9" name="TextBox 8"/>
+          <p:cNvPr id="10" name="TextBox 9"/>
           <p:cNvSpPr txBox="1"/>
           <p:nvPr/>
         </p:nvSpPr>
@@ -26967,7 +27183,7 @@
       </p:sp>
       <p:sp>
         <p:nvSpPr>
-          <p:cNvPr id="10" name="Rounded Rectangle 9"/>
+          <p:cNvPr id="11" name="Rounded Rectangle 10"/>
           <p:cNvSpPr/>
           <p:nvPr/>
         </p:nvSpPr>
@@ -27019,7 +27235,7 @@
       </p:sp>
       <p:sp>
         <p:nvSpPr>
-          <p:cNvPr id="11" name="Rounded Rectangle 10"/>
+          <p:cNvPr id="12" name="Rounded Rectangle 11"/>
           <p:cNvSpPr/>
           <p:nvPr/>
         </p:nvSpPr>
@@ -27063,9 +27279,33 @@
           </a:p>
         </p:txBody>
       </p:sp>
-      <p:sp>
-        <p:nvSpPr>
-          <p:cNvPr id="12" name="TextBox 11"/>
+      <p:pic>
+        <p:nvPicPr>
+          <p:cNvPr id="13" name="Picture 12" descr="spark_FFFFFF.png"/>
+          <p:cNvPicPr>
+            <a:picLocks noChangeAspect="1"/>
+          </p:cNvPicPr>
+          <p:nvPr/>
+        </p:nvPicPr>
+        <p:blipFill>
+          <a:blip r:embed="rId2"/>
+          <a:stretch>
+            <a:fillRect/>
+          </a:stretch>
+        </p:blipFill>
+        <p:spPr>
+          <a:xfrm>
+            <a:off x="6648602" y="2323490"/>
+            <a:ext cx="281635" cy="281635"/>
+          </a:xfrm>
+          <a:prstGeom prst="rect">
+            <a:avLst/>
+          </a:prstGeom>
+        </p:spPr>
+      </p:pic>
+      <p:sp>
+        <p:nvSpPr>
+          <p:cNvPr id="14" name="TextBox 13"/>
           <p:cNvSpPr txBox="1"/>
           <p:nvPr/>
         </p:nvSpPr>
@@ -27100,7 +27340,7 @@
       </p:sp>
       <p:sp>
         <p:nvSpPr>
-          <p:cNvPr id="13" name="TextBox 12"/>
+          <p:cNvPr id="15" name="TextBox 14"/>
           <p:cNvSpPr txBox="1"/>
           <p:nvPr/>
         </p:nvSpPr>
@@ -27135,7 +27375,7 @@
       </p:sp>
       <p:sp>
         <p:nvSpPr>
-          <p:cNvPr id="14" name="Rounded Rectangle 13"/>
+          <p:cNvPr id="16" name="Rounded Rectangle 15"/>
           <p:cNvSpPr/>
           <p:nvPr/>
         </p:nvSpPr>
@@ -27187,7 +27427,7 @@
       </p:sp>
       <p:sp>
         <p:nvSpPr>
-          <p:cNvPr id="15" name="Rounded Rectangle 14"/>
+          <p:cNvPr id="17" name="Rounded Rectangle 16"/>
           <p:cNvSpPr/>
           <p:nvPr/>
         </p:nvSpPr>
@@ -27231,9 +27471,33 @@
           </a:p>
         </p:txBody>
       </p:sp>
-      <p:sp>
-        <p:nvSpPr>
-          <p:cNvPr id="16" name="TextBox 15"/>
+      <p:pic>
+        <p:nvPicPr>
+          <p:cNvPr id="18" name="Picture 17" descr="spark_FFFFFF.png"/>
+          <p:cNvPicPr>
+            <a:picLocks noChangeAspect="1"/>
+          </p:cNvPicPr>
+          <p:nvPr/>
+        </p:nvPicPr>
+        <p:blipFill>
+          <a:blip r:embed="rId2"/>
+          <a:stretch>
+            <a:fillRect/>
+          </a:stretch>
+        </p:blipFill>
+        <p:spPr>
+          <a:xfrm>
+            <a:off x="1070762" y="4152290"/>
+            <a:ext cx="281635" cy="281635"/>
+          </a:xfrm>
+          <a:prstGeom prst="rect">
+            <a:avLst/>
+          </a:prstGeom>
+        </p:spPr>
+      </p:pic>
+      <p:sp>
+        <p:nvSpPr>
+          <p:cNvPr id="19" name="TextBox 18"/>
           <p:cNvSpPr txBox="1"/>
           <p:nvPr/>
         </p:nvSpPr>
@@ -27268,7 +27532,7 @@
       </p:sp>
       <p:sp>
         <p:nvSpPr>
-          <p:cNvPr id="17" name="TextBox 16"/>
+          <p:cNvPr id="20" name="TextBox 19"/>
           <p:cNvSpPr txBox="1"/>
           <p:nvPr/>
         </p:nvSpPr>
@@ -27303,7 +27567,7 @@
       </p:sp>
       <p:sp>
         <p:nvSpPr>
-          <p:cNvPr id="18" name="Rounded Rectangle 17"/>
+          <p:cNvPr id="21" name="Rounded Rectangle 20"/>
           <p:cNvSpPr/>
           <p:nvPr/>
         </p:nvSpPr>
@@ -27355,7 +27619,7 @@
       </p:sp>
       <p:sp>
         <p:nvSpPr>
-          <p:cNvPr id="19" name="Rounded Rectangle 18"/>
+          <p:cNvPr id="22" name="Rounded Rectangle 21"/>
           <p:cNvSpPr/>
           <p:nvPr/>
         </p:nvSpPr>
@@ -27399,9 +27663,33 @@
           </a:p>
         </p:txBody>
       </p:sp>
-      <p:sp>
-        <p:nvSpPr>
-          <p:cNvPr id="20" name="TextBox 19"/>
+      <p:pic>
+        <p:nvPicPr>
+          <p:cNvPr id="23" name="Picture 22" descr="spark_FFFFFF.png"/>
+          <p:cNvPicPr>
+            <a:picLocks noChangeAspect="1"/>
+          </p:cNvPicPr>
+          <p:nvPr/>
+        </p:nvPicPr>
+        <p:blipFill>
+          <a:blip r:embed="rId2"/>
+          <a:stretch>
+            <a:fillRect/>
+          </a:stretch>
+        </p:blipFill>
+        <p:spPr>
+          <a:xfrm>
+            <a:off x="6648602" y="4152290"/>
+            <a:ext cx="281635" cy="281635"/>
+          </a:xfrm>
+          <a:prstGeom prst="rect">
+            <a:avLst/>
+          </a:prstGeom>
+        </p:spPr>
+      </p:pic>
+      <p:sp>
+        <p:nvSpPr>
+          <p:cNvPr id="24" name="TextBox 23"/>
           <p:cNvSpPr txBox="1"/>
           <p:nvPr/>
         </p:nvSpPr>
@@ -27436,7 +27724,7 @@
       </p:sp>
       <p:sp>
         <p:nvSpPr>
-          <p:cNvPr id="21" name="TextBox 20"/>
+          <p:cNvPr id="25" name="TextBox 24"/>
           <p:cNvSpPr txBox="1"/>
           <p:nvPr/>
         </p:nvSpPr>

</xml_diff>